<commit_message>
Utilisation: take Isayah Kuhlmann out of the base — on leave
Isayah logged no hours, so billed time is unchanged at 39.45h. Only the
capacity base moves: 9 people to 8, 342h to 304h, and billable utilisation
13.0% rather than 11.5%. Stripping Rhys's 19.5h leaves 6.6%.

He also drops off the by-employee table, so Karim AlRifaii is now the only
name against "no time logged" — the summary bullet says that rather than
naming them both.

Co-Authored-By: Claude Opus 5 <noreply@anthropic.com>
Claude-Session: https://claude.ai/code/session_019YTPNjRj34XzLPLC9gKxc4
</commit_message>
<xml_diff>
--- a/exec-deck/output/H&L Weekly Update - WC 12 Oct 2026.pptx
+++ b/exec-deck/output/H&L Weekly Update - WC 12 Oct 2026.pptx
@@ -32040,7 +32040,7 @@
                 <a:ea typeface="Poppins" pitchFamily="34" charset="-122"/>
                 <a:cs typeface="Poppins" pitchFamily="34" charset="-120"/>
               </a:rPr>
-              <a:t>billable utilisation 11.5% — 39.5h of 342h; last week restated 21.3h → 30.3h, so this is a floor again</a:t>
+              <a:t>billable utilisation 13.0% — 39.5h of 304h with Isayah out; last week restated 21.3h → 30.3h, so this is a floor again</a:t>
             </a:r>
             <a:endParaRPr lang="en-US" sz="900" dirty="0"/>
           </a:p>
@@ -45932,7 +45932,7 @@
                 <a:ea typeface="Poppins" pitchFamily="34" charset="-122"/>
                 <a:cs typeface="Poppins" pitchFamily="34" charset="-120"/>
               </a:rPr>
-              <a:t>11.5%</a:t>
+              <a:t>13%</a:t>
             </a:r>
             <a:endParaRPr lang="en-US" sz="2600" dirty="0"/>
           </a:p>
@@ -45971,7 +45971,7 @@
                 <a:ea typeface="Poppins" pitchFamily="34" charset="-122"/>
                 <a:cs typeface="Poppins" pitchFamily="34" charset="-120"/>
               </a:rPr>
-              <a:t>39.45h billed of 342h available · target 50% · Rhys logged half of it</a:t>
+              <a:t>39.45h billed of 304h available · target 50% · Rhys logged half of it</a:t>
             </a:r>
             <a:endParaRPr lang="en-US" sz="780" dirty="0"/>
           </a:p>
@@ -46078,7 +46078,7 @@
                 <a:ea typeface="Poppins" pitchFamily="34" charset="-122"/>
                 <a:cs typeface="Poppins" pitchFamily="34" charset="-120"/>
               </a:rPr>
-              <a:t>342h</a:t>
+              <a:t>304h</a:t>
             </a:r>
             <a:endParaRPr lang="en-US" sz="2600" dirty="0"/>
           </a:p>
@@ -46117,7 +46117,7 @@
                 <a:ea typeface="Poppins" pitchFamily="34" charset="-122"/>
                 <a:cs typeface="Poppins" pitchFamily="34" charset="-120"/>
               </a:rPr>
-              <a:t>9 people assigned to PS-pipeline tickets × 38h standard week</a:t>
+              <a:t>8 available × 38h · Isayah Kuhlmann on leave</a:t>
             </a:r>
             <a:endParaRPr lang="en-US" sz="780" dirty="0"/>
           </a:p>
@@ -46555,7 +46555,7 @@
         <p:spPr>
           <a:xfrm>
             <a:off x="2944368" y="3017520"/>
-            <a:ext cx="5486" cy="1744675"/>
+            <a:ext cx="5486" cy="1723136"/>
           </a:xfrm>
           <a:prstGeom prst="rect">
             <a:avLst/>
@@ -46614,7 +46614,7 @@
         <p:spPr>
           <a:xfrm>
             <a:off x="3419856" y="3017520"/>
-            <a:ext cx="5486" cy="1744675"/>
+            <a:ext cx="5486" cy="1723136"/>
           </a:xfrm>
           <a:prstGeom prst="rect">
             <a:avLst/>
@@ -46673,7 +46673,7 @@
         <p:spPr>
           <a:xfrm>
             <a:off x="3895344" y="3017520"/>
-            <a:ext cx="5486" cy="1744675"/>
+            <a:ext cx="5486" cy="1723136"/>
           </a:xfrm>
           <a:prstGeom prst="rect">
             <a:avLst/>
@@ -46732,7 +46732,7 @@
         <p:spPr>
           <a:xfrm>
             <a:off x="4370832" y="3017520"/>
-            <a:ext cx="5486" cy="1744675"/>
+            <a:ext cx="5486" cy="1723136"/>
           </a:xfrm>
           <a:prstGeom prst="rect">
             <a:avLst/>
@@ -46791,7 +46791,7 @@
         <p:spPr>
           <a:xfrm>
             <a:off x="4846320" y="3017520"/>
-            <a:ext cx="5486" cy="1744675"/>
+            <a:ext cx="5486" cy="1723136"/>
           </a:xfrm>
           <a:prstGeom prst="rect">
             <a:avLst/>
@@ -46811,7 +46811,7 @@
         <p:spPr>
           <a:xfrm>
             <a:off x="640080" y="3054096"/>
-            <a:ext cx="1783080" cy="193853"/>
+            <a:ext cx="1783080" cy="215392"/>
           </a:xfrm>
           <a:prstGeom prst="rect">
             <a:avLst/>
@@ -46849,7 +46849,7 @@
         </p:nvSpPr>
         <p:spPr>
           <a:xfrm>
-            <a:off x="2468880" y="3121304"/>
+            <a:off x="2468880" y="3132074"/>
             <a:ext cx="2377440" cy="59436"/>
           </a:xfrm>
           <a:prstGeom prst="roundRect">
@@ -46871,7 +46871,7 @@
         </p:nvSpPr>
         <p:spPr>
           <a:xfrm>
-            <a:off x="2468880" y="3121304"/>
+            <a:off x="2468880" y="3132074"/>
             <a:ext cx="1219627" cy="59436"/>
           </a:xfrm>
           <a:prstGeom prst="roundRect">
@@ -46894,7 +46894,7 @@
         <p:spPr>
           <a:xfrm>
             <a:off x="5029200" y="3054096"/>
-            <a:ext cx="822960" cy="193853"/>
+            <a:ext cx="822960" cy="215392"/>
           </a:xfrm>
           <a:prstGeom prst="rect">
             <a:avLst/>
@@ -46933,7 +46933,7 @@
         <p:spPr>
           <a:xfrm>
             <a:off x="5943600" y="3054096"/>
-            <a:ext cx="822960" cy="193853"/>
+            <a:ext cx="822960" cy="215392"/>
           </a:xfrm>
           <a:prstGeom prst="rect">
             <a:avLst/>
@@ -46971,8 +46971,8 @@
         </p:nvSpPr>
         <p:spPr>
           <a:xfrm>
-            <a:off x="640080" y="3247949"/>
-            <a:ext cx="1783080" cy="193853"/>
+            <a:off x="640080" y="3269488"/>
+            <a:ext cx="1783080" cy="215392"/>
           </a:xfrm>
           <a:prstGeom prst="rect">
             <a:avLst/>
@@ -47010,7 +47010,7 @@
         </p:nvSpPr>
         <p:spPr>
           <a:xfrm>
-            <a:off x="2468880" y="3315157"/>
+            <a:off x="2468880" y="3347466"/>
             <a:ext cx="2377440" cy="59436"/>
           </a:xfrm>
           <a:prstGeom prst="roundRect">
@@ -47032,7 +47032,7 @@
         </p:nvSpPr>
         <p:spPr>
           <a:xfrm>
-            <a:off x="2468880" y="3315157"/>
+            <a:off x="2468880" y="3347466"/>
             <a:ext cx="406542" cy="59436"/>
           </a:xfrm>
           <a:prstGeom prst="roundRect">
@@ -47054,8 +47054,8 @@
         </p:nvSpPr>
         <p:spPr>
           <a:xfrm>
-            <a:off x="5029200" y="3247949"/>
-            <a:ext cx="822960" cy="193853"/>
+            <a:off x="5029200" y="3269488"/>
+            <a:ext cx="822960" cy="215392"/>
           </a:xfrm>
           <a:prstGeom prst="rect">
             <a:avLst/>
@@ -47093,8 +47093,8 @@
         </p:nvSpPr>
         <p:spPr>
           <a:xfrm>
-            <a:off x="5943600" y="3247949"/>
-            <a:ext cx="822960" cy="193853"/>
+            <a:off x="5943600" y="3269488"/>
+            <a:ext cx="822960" cy="215392"/>
           </a:xfrm>
           <a:prstGeom prst="rect">
             <a:avLst/>
@@ -47132,8 +47132,8 @@
         </p:nvSpPr>
         <p:spPr>
           <a:xfrm>
-            <a:off x="640080" y="3441802"/>
-            <a:ext cx="1783080" cy="193853"/>
+            <a:off x="640080" y="3484880"/>
+            <a:ext cx="1783080" cy="215392"/>
           </a:xfrm>
           <a:prstGeom prst="rect">
             <a:avLst/>
@@ -47171,7 +47171,7 @@
         </p:nvSpPr>
         <p:spPr>
           <a:xfrm>
-            <a:off x="2468880" y="3509010"/>
+            <a:off x="2468880" y="3562858"/>
             <a:ext cx="2377440" cy="59436"/>
           </a:xfrm>
           <a:prstGeom prst="roundRect">
@@ -47193,7 +47193,7 @@
         </p:nvSpPr>
         <p:spPr>
           <a:xfrm>
-            <a:off x="2468880" y="3509010"/>
+            <a:off x="2468880" y="3562858"/>
             <a:ext cx="358993" cy="59436"/>
           </a:xfrm>
           <a:prstGeom prst="roundRect">
@@ -47215,8 +47215,8 @@
         </p:nvSpPr>
         <p:spPr>
           <a:xfrm>
-            <a:off x="5029200" y="3441802"/>
-            <a:ext cx="822960" cy="193853"/>
+            <a:off x="5029200" y="3484880"/>
+            <a:ext cx="822960" cy="215392"/>
           </a:xfrm>
           <a:prstGeom prst="rect">
             <a:avLst/>
@@ -47254,8 +47254,8 @@
         </p:nvSpPr>
         <p:spPr>
           <a:xfrm>
-            <a:off x="5943600" y="3441802"/>
-            <a:ext cx="822960" cy="193853"/>
+            <a:off x="5943600" y="3484880"/>
+            <a:ext cx="822960" cy="215392"/>
           </a:xfrm>
           <a:prstGeom prst="rect">
             <a:avLst/>
@@ -47293,8 +47293,8 @@
         </p:nvSpPr>
         <p:spPr>
           <a:xfrm>
-            <a:off x="640080" y="3635654"/>
-            <a:ext cx="1783080" cy="193853"/>
+            <a:off x="640080" y="3700272"/>
+            <a:ext cx="1783080" cy="215392"/>
           </a:xfrm>
           <a:prstGeom prst="rect">
             <a:avLst/>
@@ -47332,7 +47332,7 @@
         </p:nvSpPr>
         <p:spPr>
           <a:xfrm>
-            <a:off x="2468880" y="3702863"/>
+            <a:off x="2468880" y="3778250"/>
             <a:ext cx="2377440" cy="59436"/>
           </a:xfrm>
           <a:prstGeom prst="roundRect">
@@ -47354,7 +47354,7 @@
         </p:nvSpPr>
         <p:spPr>
           <a:xfrm>
-            <a:off x="2468880" y="3702863"/>
+            <a:off x="2468880" y="3778250"/>
             <a:ext cx="280538" cy="59436"/>
           </a:xfrm>
           <a:prstGeom prst="roundRect">
@@ -47376,8 +47376,8 @@
         </p:nvSpPr>
         <p:spPr>
           <a:xfrm>
-            <a:off x="5029200" y="3635654"/>
-            <a:ext cx="822960" cy="193853"/>
+            <a:off x="5029200" y="3700272"/>
+            <a:ext cx="822960" cy="215392"/>
           </a:xfrm>
           <a:prstGeom prst="rect">
             <a:avLst/>
@@ -47415,8 +47415,8 @@
         </p:nvSpPr>
         <p:spPr>
           <a:xfrm>
-            <a:off x="5943600" y="3635654"/>
-            <a:ext cx="822960" cy="193853"/>
+            <a:off x="5943600" y="3700272"/>
+            <a:ext cx="822960" cy="215392"/>
           </a:xfrm>
           <a:prstGeom prst="rect">
             <a:avLst/>
@@ -47454,8 +47454,8 @@
         </p:nvSpPr>
         <p:spPr>
           <a:xfrm>
-            <a:off x="640080" y="3829507"/>
-            <a:ext cx="1783080" cy="193853"/>
+            <a:off x="640080" y="3915664"/>
+            <a:ext cx="1783080" cy="215392"/>
           </a:xfrm>
           <a:prstGeom prst="rect">
             <a:avLst/>
@@ -47493,7 +47493,7 @@
         </p:nvSpPr>
         <p:spPr>
           <a:xfrm>
-            <a:off x="2468880" y="3896716"/>
+            <a:off x="2468880" y="3993642"/>
             <a:ext cx="2377440" cy="59436"/>
           </a:xfrm>
           <a:prstGeom prst="roundRect">
@@ -47515,7 +47515,7 @@
         </p:nvSpPr>
         <p:spPr>
           <a:xfrm>
-            <a:off x="2468880" y="3896716"/>
+            <a:off x="2468880" y="3993642"/>
             <a:ext cx="92720" cy="59436"/>
           </a:xfrm>
           <a:prstGeom prst="roundRect">
@@ -47537,8 +47537,8 @@
         </p:nvSpPr>
         <p:spPr>
           <a:xfrm>
-            <a:off x="5029200" y="3829507"/>
-            <a:ext cx="822960" cy="193853"/>
+            <a:off x="5029200" y="3915664"/>
+            <a:ext cx="822960" cy="215392"/>
           </a:xfrm>
           <a:prstGeom prst="rect">
             <a:avLst/>
@@ -47576,8 +47576,8 @@
         </p:nvSpPr>
         <p:spPr>
           <a:xfrm>
-            <a:off x="5943600" y="3829507"/>
-            <a:ext cx="822960" cy="193853"/>
+            <a:off x="5943600" y="3915664"/>
+            <a:ext cx="822960" cy="215392"/>
           </a:xfrm>
           <a:prstGeom prst="rect">
             <a:avLst/>
@@ -47615,8 +47615,8 @@
         </p:nvSpPr>
         <p:spPr>
           <a:xfrm>
-            <a:off x="640080" y="4023360"/>
-            <a:ext cx="1783080" cy="193853"/>
+            <a:off x="640080" y="4131056"/>
+            <a:ext cx="1783080" cy="215392"/>
           </a:xfrm>
           <a:prstGeom prst="rect">
             <a:avLst/>
@@ -47654,7 +47654,7 @@
         </p:nvSpPr>
         <p:spPr>
           <a:xfrm>
-            <a:off x="2468880" y="4090568"/>
+            <a:off x="2468880" y="4209034"/>
             <a:ext cx="2377440" cy="59436"/>
           </a:xfrm>
           <a:prstGeom prst="roundRect">
@@ -47676,7 +47676,7 @@
         </p:nvSpPr>
         <p:spPr>
           <a:xfrm>
-            <a:off x="2468880" y="4090568"/>
+            <a:off x="2468880" y="4209034"/>
             <a:ext cx="68946" cy="59436"/>
           </a:xfrm>
           <a:prstGeom prst="roundRect">
@@ -47698,8 +47698,8 @@
         </p:nvSpPr>
         <p:spPr>
           <a:xfrm>
-            <a:off x="5029200" y="4023360"/>
-            <a:ext cx="822960" cy="193853"/>
+            <a:off x="5029200" y="4131056"/>
+            <a:ext cx="822960" cy="215392"/>
           </a:xfrm>
           <a:prstGeom prst="rect">
             <a:avLst/>
@@ -47737,8 +47737,8 @@
         </p:nvSpPr>
         <p:spPr>
           <a:xfrm>
-            <a:off x="5943600" y="4023360"/>
-            <a:ext cx="822960" cy="193853"/>
+            <a:off x="5943600" y="4131056"/>
+            <a:ext cx="822960" cy="215392"/>
           </a:xfrm>
           <a:prstGeom prst="rect">
             <a:avLst/>
@@ -47776,8 +47776,8 @@
         </p:nvSpPr>
         <p:spPr>
           <a:xfrm>
-            <a:off x="640080" y="4217213"/>
-            <a:ext cx="1783080" cy="193853"/>
+            <a:off x="640080" y="4346448"/>
+            <a:ext cx="1783080" cy="215392"/>
           </a:xfrm>
           <a:prstGeom prst="rect">
             <a:avLst/>
@@ -47815,7 +47815,7 @@
         </p:nvSpPr>
         <p:spPr>
           <a:xfrm>
-            <a:off x="2468880" y="4284421"/>
+            <a:off x="2468880" y="4424426"/>
             <a:ext cx="2377440" cy="59436"/>
           </a:xfrm>
           <a:prstGeom prst="roundRect">
@@ -47837,7 +47837,7 @@
         </p:nvSpPr>
         <p:spPr>
           <a:xfrm>
-            <a:off x="2468880" y="4284421"/>
+            <a:off x="2468880" y="4424426"/>
             <a:ext cx="45720" cy="59436"/>
           </a:xfrm>
           <a:prstGeom prst="roundRect">
@@ -47859,8 +47859,8 @@
         </p:nvSpPr>
         <p:spPr>
           <a:xfrm>
-            <a:off x="5029200" y="4217213"/>
-            <a:ext cx="822960" cy="193853"/>
+            <a:off x="5029200" y="4346448"/>
+            <a:ext cx="822960" cy="215392"/>
           </a:xfrm>
           <a:prstGeom prst="rect">
             <a:avLst/>
@@ -47898,8 +47898,8 @@
         </p:nvSpPr>
         <p:spPr>
           <a:xfrm>
-            <a:off x="5943600" y="4217213"/>
-            <a:ext cx="822960" cy="193853"/>
+            <a:off x="5943600" y="4346448"/>
+            <a:ext cx="822960" cy="215392"/>
           </a:xfrm>
           <a:prstGeom prst="rect">
             <a:avLst/>
@@ -47937,8 +47937,8 @@
         </p:nvSpPr>
         <p:spPr>
           <a:xfrm>
-            <a:off x="640080" y="4411066"/>
-            <a:ext cx="1783080" cy="193853"/>
+            <a:off x="640080" y="4561840"/>
+            <a:ext cx="1783080" cy="215392"/>
           </a:xfrm>
           <a:prstGeom prst="rect">
             <a:avLst/>
@@ -47962,7 +47962,7 @@
                 <a:ea typeface="Poppins" pitchFamily="34" charset="-122"/>
                 <a:cs typeface="Poppins" pitchFamily="34" charset="-120"/>
               </a:rPr>
-              <a:t>Isayah Kuhlmann</a:t>
+              <a:t>Karim AlRifaii</a:t>
             </a:r>
             <a:endParaRPr lang="en-US" sz="800" dirty="0"/>
           </a:p>
@@ -47976,7 +47976,7 @@
         </p:nvSpPr>
         <p:spPr>
           <a:xfrm>
-            <a:off x="2468880" y="4478274"/>
+            <a:off x="2468880" y="4639818"/>
             <a:ext cx="2377440" cy="59436"/>
           </a:xfrm>
           <a:prstGeom prst="roundRect">
@@ -47998,8 +47998,8 @@
         </p:nvSpPr>
         <p:spPr>
           <a:xfrm>
-            <a:off x="5029200" y="4411066"/>
-            <a:ext cx="822960" cy="193853"/>
+            <a:off x="5029200" y="4561840"/>
+            <a:ext cx="822960" cy="215392"/>
           </a:xfrm>
           <a:prstGeom prst="rect">
             <a:avLst/>
@@ -48037,8 +48037,8 @@
         </p:nvSpPr>
         <p:spPr>
           <a:xfrm>
-            <a:off x="5943600" y="4411066"/>
-            <a:ext cx="822960" cy="193853"/>
+            <a:off x="5943600" y="4561840"/>
+            <a:ext cx="822960" cy="215392"/>
           </a:xfrm>
           <a:prstGeom prst="rect">
             <a:avLst/>
@@ -48070,14 +48070,34 @@
       </p:sp>
       <p:sp>
         <p:nvSpPr>
-          <p:cNvPr id="82" name="Text 80"/>
-          <p:cNvSpPr txBox="1"/>
-          <p:nvPr/>
-        </p:nvSpPr>
-        <p:spPr>
-          <a:xfrm>
-            <a:off x="640080" y="4604918"/>
-            <a:ext cx="1783080" cy="193853"/>
+          <p:cNvPr id="82" name="Shape 80"/>
+          <p:cNvSpPr/>
+          <p:nvPr/>
+        </p:nvSpPr>
+        <p:spPr>
+          <a:xfrm>
+            <a:off x="640080" y="4795520"/>
+            <a:ext cx="6126480" cy="10973"/>
+          </a:xfrm>
+          <a:prstGeom prst="rect">
+            <a:avLst/>
+          </a:prstGeom>
+          <a:solidFill>
+            <a:srgbClr val="12293A"/>
+          </a:solidFill>
+          <a:ln/>
+        </p:spPr>
+      </p:sp>
+      <p:sp>
+        <p:nvSpPr>
+          <p:cNvPr id="83" name="Text 81"/>
+          <p:cNvSpPr txBox="1"/>
+          <p:nvPr/>
+        </p:nvSpPr>
+        <p:spPr>
+          <a:xfrm>
+            <a:off x="640080" y="4822952"/>
+            <a:ext cx="1783080" cy="215392"/>
           </a:xfrm>
           <a:prstGeom prst="rect">
             <a:avLst/>
@@ -48093,7 +48113,46 @@
               <a:buNone/>
             </a:pPr>
             <a:r>
-              <a:rPr lang="en-US" sz="800" dirty="0">
+              <a:rPr lang="en-US" sz="850" b="1" dirty="0">
+                <a:solidFill>
+                  <a:srgbClr val="12293A"/>
+                </a:solidFill>
+                <a:latin typeface="Poppins" pitchFamily="34" charset="0"/>
+                <a:ea typeface="Poppins" pitchFamily="34" charset="-122"/>
+                <a:cs typeface="Poppins" pitchFamily="34" charset="-120"/>
+              </a:rPr>
+              <a:t>TOTAL</a:t>
+            </a:r>
+            <a:endParaRPr lang="en-US" sz="850" dirty="0"/>
+          </a:p>
+        </p:txBody>
+      </p:sp>
+      <p:sp>
+        <p:nvSpPr>
+          <p:cNvPr id="84" name="Text 82"/>
+          <p:cNvSpPr txBox="1"/>
+          <p:nvPr/>
+        </p:nvSpPr>
+        <p:spPr>
+          <a:xfrm>
+            <a:off x="2468880" y="4822952"/>
+            <a:ext cx="2377440" cy="215392"/>
+          </a:xfrm>
+          <a:prstGeom prst="rect">
+            <a:avLst/>
+          </a:prstGeom>
+          <a:noFill/>
+          <a:ln/>
+        </p:spPr>
+        <p:txBody>
+          <a:bodyPr wrap="square" lIns="0" tIns="0" rIns="0" bIns="0" rtlCol="0" anchor="ctr"/>
+          <a:lstStyle/>
+          <a:p>
+            <a:pPr indent="0" marL="0">
+              <a:buNone/>
+            </a:pPr>
+            <a:r>
+              <a:rPr lang="en-US" sz="700" dirty="0">
                 <a:solidFill>
                   <a:srgbClr val="5E7280"/>
                 </a:solidFill>
@@ -48101,44 +48160,22 @@
                 <a:ea typeface="Poppins" pitchFamily="34" charset="-122"/>
                 <a:cs typeface="Poppins" pitchFamily="34" charset="-120"/>
               </a:rPr>
-              <a:t>Karim AlRifaii</a:t>
-            </a:r>
-            <a:endParaRPr lang="en-US" sz="800" dirty="0"/>
-          </a:p>
-        </p:txBody>
-      </p:sp>
-      <p:sp>
-        <p:nvSpPr>
-          <p:cNvPr id="83" name="Shape 81"/>
-          <p:cNvSpPr/>
-          <p:nvPr/>
-        </p:nvSpPr>
-        <p:spPr>
-          <a:xfrm>
-            <a:off x="2468880" y="4672127"/>
-            <a:ext cx="2377440" cy="59436"/>
-          </a:xfrm>
-          <a:prstGeom prst="roundRect">
-            <a:avLst>
-              <a:gd name="adj" fmla="val 49231"/>
-            </a:avLst>
-          </a:prstGeom>
-          <a:solidFill>
-            <a:srgbClr val="E2EAEE"/>
-          </a:solidFill>
-          <a:ln/>
-        </p:spPr>
-      </p:sp>
-      <p:sp>
-        <p:nvSpPr>
-          <p:cNvPr id="84" name="Text 82"/>
-          <p:cNvSpPr txBox="1"/>
-          <p:nvPr/>
-        </p:nvSpPr>
-        <p:spPr>
-          <a:xfrm>
-            <a:off x="5029200" y="4604918"/>
-            <a:ext cx="822960" cy="193853"/>
+              <a:t>8 PS people × 38h = 304h available</a:t>
+            </a:r>
+            <a:endParaRPr lang="en-US" sz="700" dirty="0"/>
+          </a:p>
+        </p:txBody>
+      </p:sp>
+      <p:sp>
+        <p:nvSpPr>
+          <p:cNvPr id="85" name="Text 83"/>
+          <p:cNvSpPr txBox="1"/>
+          <p:nvPr/>
+        </p:nvSpPr>
+        <p:spPr>
+          <a:xfrm>
+            <a:off x="5029200" y="4822952"/>
+            <a:ext cx="822960" cy="215392"/>
           </a:xfrm>
           <a:prstGeom prst="rect">
             <a:avLst/>
@@ -48154,30 +48191,30 @@
               <a:buNone/>
             </a:pPr>
             <a:r>
-              <a:rPr lang="en-US" sz="800" dirty="0">
-                <a:solidFill>
-                  <a:srgbClr val="8FA1AC"/>
-                </a:solidFill>
-                <a:latin typeface="Poppins" pitchFamily="34" charset="0"/>
-                <a:ea typeface="Poppins" pitchFamily="34" charset="-122"/>
-                <a:cs typeface="Poppins" pitchFamily="34" charset="-120"/>
-              </a:rPr>
-              <a:t>—</a:t>
-            </a:r>
-            <a:endParaRPr lang="en-US" sz="800" dirty="0"/>
-          </a:p>
-        </p:txBody>
-      </p:sp>
-      <p:sp>
-        <p:nvSpPr>
-          <p:cNvPr id="85" name="Text 83"/>
-          <p:cNvSpPr txBox="1"/>
-          <p:nvPr/>
-        </p:nvSpPr>
-        <p:spPr>
-          <a:xfrm>
-            <a:off x="5943600" y="4604918"/>
-            <a:ext cx="822960" cy="193853"/>
+              <a:rPr lang="en-US" sz="950" b="1" dirty="0">
+                <a:solidFill>
+                  <a:srgbClr val="2C8394"/>
+                </a:solidFill>
+                <a:latin typeface="Poppins" pitchFamily="34" charset="0"/>
+                <a:ea typeface="Poppins" pitchFamily="34" charset="-122"/>
+                <a:cs typeface="Poppins" pitchFamily="34" charset="-120"/>
+              </a:rPr>
+              <a:t>39.45h</a:t>
+            </a:r>
+            <a:endParaRPr lang="en-US" sz="950" dirty="0"/>
+          </a:p>
+        </p:txBody>
+      </p:sp>
+      <p:sp>
+        <p:nvSpPr>
+          <p:cNvPr id="86" name="Text 84"/>
+          <p:cNvSpPr txBox="1"/>
+          <p:nvPr/>
+        </p:nvSpPr>
+        <p:spPr>
+          <a:xfrm>
+            <a:off x="5943600" y="4822952"/>
+            <a:ext cx="822960" cy="215392"/>
           </a:xfrm>
           <a:prstGeom prst="rect">
             <a:avLst/>
@@ -48193,199 +48230,23 @@
               <a:buNone/>
             </a:pPr>
             <a:r>
-              <a:rPr lang="en-US" sz="600" dirty="0">
-                <a:solidFill>
-                  <a:srgbClr val="8FA1AC"/>
-                </a:solidFill>
-                <a:latin typeface="Poppins" pitchFamily="34" charset="0"/>
-                <a:ea typeface="Poppins" pitchFamily="34" charset="-122"/>
-                <a:cs typeface="Poppins" pitchFamily="34" charset="-120"/>
-              </a:rPr>
-              <a:t>no time logged</a:t>
-            </a:r>
-            <a:endParaRPr lang="en-US" sz="600" dirty="0"/>
-          </a:p>
-        </p:txBody>
-      </p:sp>
-      <p:sp>
-        <p:nvSpPr>
-          <p:cNvPr id="86" name="Shape 84"/>
-          <p:cNvSpPr/>
-          <p:nvPr/>
-        </p:nvSpPr>
-        <p:spPr>
-          <a:xfrm>
-            <a:off x="640080" y="4817059"/>
-            <a:ext cx="6126480" cy="10973"/>
-          </a:xfrm>
-          <a:prstGeom prst="rect">
-            <a:avLst/>
-          </a:prstGeom>
-          <a:solidFill>
-            <a:srgbClr val="12293A"/>
-          </a:solidFill>
-          <a:ln/>
-        </p:spPr>
+              <a:rPr lang="en-US" sz="950" b="1" dirty="0">
+                <a:solidFill>
+                  <a:srgbClr val="C88A2E"/>
+                </a:solidFill>
+                <a:latin typeface="Poppins" pitchFamily="34" charset="0"/>
+                <a:ea typeface="Poppins" pitchFamily="34" charset="-122"/>
+                <a:cs typeface="Poppins" pitchFamily="34" charset="-120"/>
+              </a:rPr>
+              <a:t>13.0%</a:t>
+            </a:r>
+            <a:endParaRPr lang="en-US" sz="950" dirty="0"/>
+          </a:p>
+        </p:txBody>
       </p:sp>
       <p:sp>
         <p:nvSpPr>
           <p:cNvPr id="87" name="Text 85"/>
-          <p:cNvSpPr txBox="1"/>
-          <p:nvPr/>
-        </p:nvSpPr>
-        <p:spPr>
-          <a:xfrm>
-            <a:off x="640080" y="4844491"/>
-            <a:ext cx="1783080" cy="193853"/>
-          </a:xfrm>
-          <a:prstGeom prst="rect">
-            <a:avLst/>
-          </a:prstGeom>
-          <a:noFill/>
-          <a:ln/>
-        </p:spPr>
-        <p:txBody>
-          <a:bodyPr wrap="square" lIns="0" tIns="0" rIns="0" bIns="0" rtlCol="0" anchor="ctr"/>
-          <a:lstStyle/>
-          <a:p>
-            <a:pPr indent="0" marL="0">
-              <a:buNone/>
-            </a:pPr>
-            <a:r>
-              <a:rPr lang="en-US" sz="850" b="1" dirty="0">
-                <a:solidFill>
-                  <a:srgbClr val="12293A"/>
-                </a:solidFill>
-                <a:latin typeface="Poppins" pitchFamily="34" charset="0"/>
-                <a:ea typeface="Poppins" pitchFamily="34" charset="-122"/>
-                <a:cs typeface="Poppins" pitchFamily="34" charset="-120"/>
-              </a:rPr>
-              <a:t>TOTAL</a:t>
-            </a:r>
-            <a:endParaRPr lang="en-US" sz="850" dirty="0"/>
-          </a:p>
-        </p:txBody>
-      </p:sp>
-      <p:sp>
-        <p:nvSpPr>
-          <p:cNvPr id="88" name="Text 86"/>
-          <p:cNvSpPr txBox="1"/>
-          <p:nvPr/>
-        </p:nvSpPr>
-        <p:spPr>
-          <a:xfrm>
-            <a:off x="2468880" y="4844491"/>
-            <a:ext cx="2377440" cy="193853"/>
-          </a:xfrm>
-          <a:prstGeom prst="rect">
-            <a:avLst/>
-          </a:prstGeom>
-          <a:noFill/>
-          <a:ln/>
-        </p:spPr>
-        <p:txBody>
-          <a:bodyPr wrap="square" lIns="0" tIns="0" rIns="0" bIns="0" rtlCol="0" anchor="ctr"/>
-          <a:lstStyle/>
-          <a:p>
-            <a:pPr indent="0" marL="0">
-              <a:buNone/>
-            </a:pPr>
-            <a:r>
-              <a:rPr lang="en-US" sz="700" dirty="0">
-                <a:solidFill>
-                  <a:srgbClr val="5E7280"/>
-                </a:solidFill>
-                <a:latin typeface="Poppins" pitchFamily="34" charset="0"/>
-                <a:ea typeface="Poppins" pitchFamily="34" charset="-122"/>
-                <a:cs typeface="Poppins" pitchFamily="34" charset="-120"/>
-              </a:rPr>
-              <a:t>9 PS people × 38h = 342h available</a:t>
-            </a:r>
-            <a:endParaRPr lang="en-US" sz="700" dirty="0"/>
-          </a:p>
-        </p:txBody>
-      </p:sp>
-      <p:sp>
-        <p:nvSpPr>
-          <p:cNvPr id="89" name="Text 87"/>
-          <p:cNvSpPr txBox="1"/>
-          <p:nvPr/>
-        </p:nvSpPr>
-        <p:spPr>
-          <a:xfrm>
-            <a:off x="5029200" y="4844491"/>
-            <a:ext cx="822960" cy="193853"/>
-          </a:xfrm>
-          <a:prstGeom prst="rect">
-            <a:avLst/>
-          </a:prstGeom>
-          <a:noFill/>
-          <a:ln/>
-        </p:spPr>
-        <p:txBody>
-          <a:bodyPr wrap="square" lIns="0" tIns="0" rIns="0" bIns="0" rtlCol="0" anchor="ctr"/>
-          <a:lstStyle/>
-          <a:p>
-            <a:pPr algn="r" indent="0" marL="0">
-              <a:buNone/>
-            </a:pPr>
-            <a:r>
-              <a:rPr lang="en-US" sz="950" b="1" dirty="0">
-                <a:solidFill>
-                  <a:srgbClr val="2C8394"/>
-                </a:solidFill>
-                <a:latin typeface="Poppins" pitchFamily="34" charset="0"/>
-                <a:ea typeface="Poppins" pitchFamily="34" charset="-122"/>
-                <a:cs typeface="Poppins" pitchFamily="34" charset="-120"/>
-              </a:rPr>
-              <a:t>39.45h</a:t>
-            </a:r>
-            <a:endParaRPr lang="en-US" sz="950" dirty="0"/>
-          </a:p>
-        </p:txBody>
-      </p:sp>
-      <p:sp>
-        <p:nvSpPr>
-          <p:cNvPr id="90" name="Text 88"/>
-          <p:cNvSpPr txBox="1"/>
-          <p:nvPr/>
-        </p:nvSpPr>
-        <p:spPr>
-          <a:xfrm>
-            <a:off x="5943600" y="4844491"/>
-            <a:ext cx="822960" cy="193853"/>
-          </a:xfrm>
-          <a:prstGeom prst="rect">
-            <a:avLst/>
-          </a:prstGeom>
-          <a:noFill/>
-          <a:ln/>
-        </p:spPr>
-        <p:txBody>
-          <a:bodyPr wrap="square" lIns="0" tIns="0" rIns="0" bIns="0" rtlCol="0" anchor="ctr"/>
-          <a:lstStyle/>
-          <a:p>
-            <a:pPr algn="r" indent="0" marL="0">
-              <a:buNone/>
-            </a:pPr>
-            <a:r>
-              <a:rPr lang="en-US" sz="950" b="1" dirty="0">
-                <a:solidFill>
-                  <a:srgbClr val="C88A2E"/>
-                </a:solidFill>
-                <a:latin typeface="Poppins" pitchFamily="34" charset="0"/>
-                <a:ea typeface="Poppins" pitchFamily="34" charset="-122"/>
-                <a:cs typeface="Poppins" pitchFamily="34" charset="-120"/>
-              </a:rPr>
-              <a:t>11.5%</a:t>
-            </a:r>
-            <a:endParaRPr lang="en-US" sz="950" dirty="0"/>
-          </a:p>
-        </p:txBody>
-      </p:sp>
-      <p:sp>
-        <p:nvSpPr>
-          <p:cNvPr id="91" name="Text 89"/>
           <p:cNvSpPr txBox="1"/>
           <p:nvPr/>
         </p:nvSpPr>
@@ -48416,7 +48277,7 @@
                 <a:ea typeface="Poppins" pitchFamily="34" charset="-122"/>
                 <a:cs typeface="Poppins" pitchFamily="34" charset="-120"/>
               </a:rPr>
-              <a:t>Available staff = the 9 Professional Services people holding PS-pipeline tickets this week, at 38h each. No leave reported. Lopez, Hikuroa, Magabo, Ho, Fenwick and Hettiarachchy hold PS tickets but are not PS staff — they and their hours are excluded; none carried hours this week.</a:t>
+              <a:t>Available staff = the 8 Professional Services people holding PS-pipeline tickets this week and not on leave, at 38h each. Isayah Kuhlmann was on leave and is out of the base. Lopez, Hikuroa, Magabo, Ho, Fenwick and Hettiarachchy hold PS tickets but are not PS staff — they and their hours are excluded; none carried hours this week.</a:t>
             </a:r>
             <a:endParaRPr lang="en-US" sz="580" dirty="0"/>
           </a:p>
@@ -48424,7 +48285,7 @@
       </p:sp>
       <p:sp>
         <p:nvSpPr>
-          <p:cNvPr id="92" name="Shape 90"/>
+          <p:cNvPr id="88" name="Shape 86"/>
           <p:cNvSpPr/>
           <p:nvPr/>
         </p:nvSpPr>
@@ -48453,7 +48314,7 @@
       </p:sp>
       <p:sp>
         <p:nvSpPr>
-          <p:cNvPr id="93" name="Text 91"/>
+          <p:cNvPr id="89" name="Text 87"/>
           <p:cNvSpPr txBox="1"/>
           <p:nvPr/>
         </p:nvSpPr>
@@ -48506,7 +48367,7 @@
       </p:sp>
       <p:sp>
         <p:nvSpPr>
-          <p:cNvPr id="94" name="Text 92"/>
+          <p:cNvPr id="90" name="Text 88"/>
           <p:cNvSpPr txBox="1"/>
           <p:nvPr/>
         </p:nvSpPr>
@@ -48545,7 +48406,7 @@
       </p:sp>
       <p:sp>
         <p:nvSpPr>
-          <p:cNvPr id="95" name="Text 93"/>
+          <p:cNvPr id="91" name="Text 89"/>
           <p:cNvSpPr txBox="1"/>
           <p:nvPr/>
         </p:nvSpPr>
@@ -48584,7 +48445,7 @@
       </p:sp>
       <p:sp>
         <p:nvSpPr>
-          <p:cNvPr id="96" name="Text 94"/>
+          <p:cNvPr id="92" name="Text 90"/>
           <p:cNvSpPr txBox="1"/>
           <p:nvPr/>
         </p:nvSpPr>
@@ -48623,7 +48484,7 @@
       </p:sp>
       <p:sp>
         <p:nvSpPr>
-          <p:cNvPr id="97" name="Text 95"/>
+          <p:cNvPr id="93" name="Text 91"/>
           <p:cNvSpPr txBox="1"/>
           <p:nvPr/>
         </p:nvSpPr>
@@ -48662,7 +48523,7 @@
       </p:sp>
       <p:sp>
         <p:nvSpPr>
-          <p:cNvPr id="98" name="Shape 96"/>
+          <p:cNvPr id="94" name="Shape 92"/>
           <p:cNvSpPr/>
           <p:nvPr/>
         </p:nvSpPr>
@@ -48684,7 +48545,7 @@
       </p:sp>
       <p:sp>
         <p:nvSpPr>
-          <p:cNvPr id="99" name="Shape 97"/>
+          <p:cNvPr id="95" name="Shape 93"/>
           <p:cNvSpPr/>
           <p:nvPr/>
         </p:nvSpPr>
@@ -48706,7 +48567,7 @@
       </p:sp>
       <p:sp>
         <p:nvSpPr>
-          <p:cNvPr id="100" name="Text 98"/>
+          <p:cNvPr id="96" name="Text 94"/>
           <p:cNvSpPr txBox="1"/>
           <p:nvPr/>
         </p:nvSpPr>
@@ -48745,7 +48606,7 @@
       </p:sp>
       <p:sp>
         <p:nvSpPr>
-          <p:cNvPr id="101" name="Text 99"/>
+          <p:cNvPr id="97" name="Text 95"/>
           <p:cNvSpPr txBox="1"/>
           <p:nvPr/>
         </p:nvSpPr>
@@ -48784,7 +48645,7 @@
       </p:sp>
       <p:sp>
         <p:nvSpPr>
-          <p:cNvPr id="102" name="Text 100"/>
+          <p:cNvPr id="98" name="Text 96"/>
           <p:cNvSpPr txBox="1"/>
           <p:nvPr/>
         </p:nvSpPr>
@@ -48823,7 +48684,7 @@
       </p:sp>
       <p:sp>
         <p:nvSpPr>
-          <p:cNvPr id="103" name="Shape 101"/>
+          <p:cNvPr id="99" name="Shape 97"/>
           <p:cNvSpPr/>
           <p:nvPr/>
         </p:nvSpPr>
@@ -48845,7 +48706,7 @@
       </p:sp>
       <p:sp>
         <p:nvSpPr>
-          <p:cNvPr id="104" name="Shape 102"/>
+          <p:cNvPr id="100" name="Shape 98"/>
           <p:cNvSpPr/>
           <p:nvPr/>
         </p:nvSpPr>
@@ -48867,7 +48728,7 @@
       </p:sp>
       <p:sp>
         <p:nvSpPr>
-          <p:cNvPr id="105" name="Text 103"/>
+          <p:cNvPr id="101" name="Text 99"/>
           <p:cNvSpPr txBox="1"/>
           <p:nvPr/>
         </p:nvSpPr>
@@ -48906,7 +48767,7 @@
       </p:sp>
       <p:sp>
         <p:nvSpPr>
-          <p:cNvPr id="106" name="Text 104"/>
+          <p:cNvPr id="102" name="Text 100"/>
           <p:cNvSpPr txBox="1"/>
           <p:nvPr/>
         </p:nvSpPr>
@@ -48945,7 +48806,7 @@
       </p:sp>
       <p:sp>
         <p:nvSpPr>
-          <p:cNvPr id="107" name="Text 105"/>
+          <p:cNvPr id="103" name="Text 101"/>
           <p:cNvSpPr txBox="1"/>
           <p:nvPr/>
         </p:nvSpPr>
@@ -48984,7 +48845,7 @@
       </p:sp>
       <p:sp>
         <p:nvSpPr>
-          <p:cNvPr id="108" name="Shape 106"/>
+          <p:cNvPr id="104" name="Shape 102"/>
           <p:cNvSpPr/>
           <p:nvPr/>
         </p:nvSpPr>
@@ -49006,7 +48867,7 @@
       </p:sp>
       <p:sp>
         <p:nvSpPr>
-          <p:cNvPr id="109" name="Shape 107"/>
+          <p:cNvPr id="105" name="Shape 103"/>
           <p:cNvSpPr/>
           <p:nvPr/>
         </p:nvSpPr>
@@ -49028,7 +48889,7 @@
       </p:sp>
       <p:sp>
         <p:nvSpPr>
-          <p:cNvPr id="110" name="Text 108"/>
+          <p:cNvPr id="106" name="Text 104"/>
           <p:cNvSpPr txBox="1"/>
           <p:nvPr/>
         </p:nvSpPr>
@@ -49067,7 +48928,7 @@
       </p:sp>
       <p:sp>
         <p:nvSpPr>
-          <p:cNvPr id="111" name="Text 109"/>
+          <p:cNvPr id="107" name="Text 105"/>
           <p:cNvSpPr txBox="1"/>
           <p:nvPr/>
         </p:nvSpPr>
@@ -49106,7 +48967,7 @@
       </p:sp>
       <p:sp>
         <p:nvSpPr>
-          <p:cNvPr id="112" name="Text 110"/>
+          <p:cNvPr id="108" name="Text 106"/>
           <p:cNvSpPr txBox="1"/>
           <p:nvPr/>
         </p:nvSpPr>
@@ -49145,7 +49006,7 @@
       </p:sp>
       <p:sp>
         <p:nvSpPr>
-          <p:cNvPr id="113" name="Shape 111"/>
+          <p:cNvPr id="109" name="Shape 107"/>
           <p:cNvSpPr/>
           <p:nvPr/>
         </p:nvSpPr>
@@ -49167,7 +49028,7 @@
       </p:sp>
       <p:sp>
         <p:nvSpPr>
-          <p:cNvPr id="114" name="Shape 112"/>
+          <p:cNvPr id="110" name="Shape 108"/>
           <p:cNvSpPr/>
           <p:nvPr/>
         </p:nvSpPr>
@@ -49189,7 +49050,7 @@
       </p:sp>
       <p:sp>
         <p:nvSpPr>
-          <p:cNvPr id="115" name="Text 113"/>
+          <p:cNvPr id="111" name="Text 109"/>
           <p:cNvSpPr txBox="1"/>
           <p:nvPr/>
         </p:nvSpPr>
@@ -49228,7 +49089,7 @@
       </p:sp>
       <p:sp>
         <p:nvSpPr>
-          <p:cNvPr id="116" name="Text 114"/>
+          <p:cNvPr id="112" name="Text 110"/>
           <p:cNvSpPr txBox="1"/>
           <p:nvPr/>
         </p:nvSpPr>
@@ -49267,7 +49128,7 @@
       </p:sp>
       <p:sp>
         <p:nvSpPr>
-          <p:cNvPr id="117" name="Text 115"/>
+          <p:cNvPr id="113" name="Text 111"/>
           <p:cNvSpPr txBox="1"/>
           <p:nvPr/>
         </p:nvSpPr>
@@ -49306,7 +49167,7 @@
       </p:sp>
       <p:sp>
         <p:nvSpPr>
-          <p:cNvPr id="118" name="Shape 116"/>
+          <p:cNvPr id="114" name="Shape 112"/>
           <p:cNvSpPr/>
           <p:nvPr/>
         </p:nvSpPr>
@@ -49328,7 +49189,7 @@
       </p:sp>
       <p:sp>
         <p:nvSpPr>
-          <p:cNvPr id="119" name="Text 117"/>
+          <p:cNvPr id="115" name="Text 113"/>
           <p:cNvSpPr txBox="1"/>
           <p:nvPr/>
         </p:nvSpPr>
@@ -49367,7 +49228,7 @@
       </p:sp>
       <p:sp>
         <p:nvSpPr>
-          <p:cNvPr id="120" name="Text 118"/>
+          <p:cNvPr id="116" name="Text 114"/>
           <p:cNvSpPr txBox="1"/>
           <p:nvPr/>
         </p:nvSpPr>
@@ -49406,7 +49267,7 @@
       </p:sp>
       <p:sp>
         <p:nvSpPr>
-          <p:cNvPr id="121" name="Shape 119"/>
+          <p:cNvPr id="117" name="Shape 115"/>
           <p:cNvSpPr/>
           <p:nvPr/>
         </p:nvSpPr>
@@ -49426,7 +49287,7 @@
       </p:sp>
       <p:sp>
         <p:nvSpPr>
-          <p:cNvPr id="122" name="Text 120"/>
+          <p:cNvPr id="118" name="Text 116"/>
           <p:cNvSpPr txBox="1"/>
           <p:nvPr/>
         </p:nvSpPr>
@@ -49465,7 +49326,7 @@
       </p:sp>
       <p:sp>
         <p:nvSpPr>
-          <p:cNvPr id="123" name="Text 121"/>
+          <p:cNvPr id="119" name="Text 117"/>
           <p:cNvSpPr txBox="1"/>
           <p:nvPr/>
         </p:nvSpPr>
@@ -49504,7 +49365,7 @@
       </p:sp>
       <p:sp>
         <p:nvSpPr>
-          <p:cNvPr id="124" name="Text 122"/>
+          <p:cNvPr id="120" name="Text 118"/>
           <p:cNvSpPr txBox="1"/>
           <p:nvPr/>
         </p:nvSpPr>
@@ -49543,7 +49404,7 @@
       </p:sp>
       <p:sp>
         <p:nvSpPr>
-          <p:cNvPr id="125" name="Text 123"/>
+          <p:cNvPr id="121" name="Text 119"/>
           <p:cNvSpPr txBox="1"/>
           <p:nvPr/>
         </p:nvSpPr>
@@ -49582,7 +49443,7 @@
       </p:sp>
       <p:sp>
         <p:nvSpPr>
-          <p:cNvPr id="126" name="Shape 124"/>
+          <p:cNvPr id="122" name="Shape 120"/>
           <p:cNvSpPr/>
           <p:nvPr/>
         </p:nvSpPr>
@@ -49611,7 +49472,7 @@
       </p:sp>
       <p:sp>
         <p:nvSpPr>
-          <p:cNvPr id="127" name="Text 125"/>
+          <p:cNvPr id="123" name="Text 121"/>
           <p:cNvSpPr txBox="1"/>
           <p:nvPr/>
         </p:nvSpPr>
@@ -49664,7 +49525,7 @@
       </p:sp>
       <p:sp>
         <p:nvSpPr>
-          <p:cNvPr id="128" name="Text 126"/>
+          <p:cNvPr id="124" name="Text 122"/>
           <p:cNvSpPr txBox="1"/>
           <p:nvPr/>
         </p:nvSpPr>
@@ -49703,7 +49564,7 @@
       </p:sp>
       <p:sp>
         <p:nvSpPr>
-          <p:cNvPr id="129" name="Text 127"/>
+          <p:cNvPr id="125" name="Text 123"/>
           <p:cNvSpPr txBox="1"/>
           <p:nvPr/>
         </p:nvSpPr>
@@ -49742,7 +49603,7 @@
       </p:sp>
       <p:sp>
         <p:nvSpPr>
-          <p:cNvPr id="130" name="Text 128"/>
+          <p:cNvPr id="126" name="Text 124"/>
           <p:cNvSpPr txBox="1"/>
           <p:nvPr/>
         </p:nvSpPr>
@@ -49781,7 +49642,7 @@
       </p:sp>
       <p:sp>
         <p:nvSpPr>
-          <p:cNvPr id="131" name="Text 129"/>
+          <p:cNvPr id="127" name="Text 125"/>
           <p:cNvSpPr txBox="1"/>
           <p:nvPr/>
         </p:nvSpPr>
@@ -49820,7 +49681,7 @@
       </p:sp>
       <p:sp>
         <p:nvSpPr>
-          <p:cNvPr id="132" name="Text 130"/>
+          <p:cNvPr id="128" name="Text 126"/>
           <p:cNvSpPr txBox="1"/>
           <p:nvPr/>
         </p:nvSpPr>
@@ -49859,7 +49720,7 @@
       </p:sp>
       <p:sp>
         <p:nvSpPr>
-          <p:cNvPr id="133" name="Shape 131"/>
+          <p:cNvPr id="129" name="Shape 127"/>
           <p:cNvSpPr/>
           <p:nvPr/>
         </p:nvSpPr>
@@ -49879,7 +49740,7 @@
       </p:sp>
       <p:sp>
         <p:nvSpPr>
-          <p:cNvPr id="134" name="Text 132"/>
+          <p:cNvPr id="130" name="Text 128"/>
           <p:cNvSpPr txBox="1"/>
           <p:nvPr/>
         </p:nvSpPr>
@@ -49918,7 +49779,7 @@
       </p:sp>
       <p:sp>
         <p:nvSpPr>
-          <p:cNvPr id="135" name="Text 133"/>
+          <p:cNvPr id="131" name="Text 129"/>
           <p:cNvSpPr txBox="1"/>
           <p:nvPr/>
         </p:nvSpPr>
@@ -49957,7 +49818,7 @@
       </p:sp>
       <p:sp>
         <p:nvSpPr>
-          <p:cNvPr id="136" name="Text 134"/>
+          <p:cNvPr id="132" name="Text 130"/>
           <p:cNvSpPr txBox="1"/>
           <p:nvPr/>
         </p:nvSpPr>
@@ -49996,7 +49857,7 @@
       </p:sp>
       <p:sp>
         <p:nvSpPr>
-          <p:cNvPr id="137" name="Text 135"/>
+          <p:cNvPr id="133" name="Text 131"/>
           <p:cNvSpPr txBox="1"/>
           <p:nvPr/>
         </p:nvSpPr>
@@ -50035,7 +49896,7 @@
       </p:sp>
       <p:sp>
         <p:nvSpPr>
-          <p:cNvPr id="138" name="Text 136"/>
+          <p:cNvPr id="134" name="Text 132"/>
           <p:cNvSpPr txBox="1"/>
           <p:nvPr/>
         </p:nvSpPr>
@@ -50074,7 +49935,7 @@
       </p:sp>
       <p:sp>
         <p:nvSpPr>
-          <p:cNvPr id="139" name="Shape 137"/>
+          <p:cNvPr id="135" name="Shape 133"/>
           <p:cNvSpPr/>
           <p:nvPr/>
         </p:nvSpPr>
@@ -50094,7 +49955,7 @@
       </p:sp>
       <p:sp>
         <p:nvSpPr>
-          <p:cNvPr id="140" name="Text 138"/>
+          <p:cNvPr id="136" name="Text 134"/>
           <p:cNvSpPr txBox="1"/>
           <p:nvPr/>
         </p:nvSpPr>
@@ -50133,7 +49994,7 @@
       </p:sp>
       <p:sp>
         <p:nvSpPr>
-          <p:cNvPr id="141" name="Text 139"/>
+          <p:cNvPr id="137" name="Text 135"/>
           <p:cNvSpPr txBox="1"/>
           <p:nvPr/>
         </p:nvSpPr>
@@ -50172,7 +50033,7 @@
       </p:sp>
       <p:sp>
         <p:nvSpPr>
-          <p:cNvPr id="142" name="Text 140"/>
+          <p:cNvPr id="138" name="Text 136"/>
           <p:cNvSpPr txBox="1"/>
           <p:nvPr/>
         </p:nvSpPr>
@@ -50211,7 +50072,7 @@
       </p:sp>
       <p:sp>
         <p:nvSpPr>
-          <p:cNvPr id="143" name="Text 141"/>
+          <p:cNvPr id="139" name="Text 137"/>
           <p:cNvSpPr txBox="1"/>
           <p:nvPr/>
         </p:nvSpPr>
@@ -50250,7 +50111,7 @@
       </p:sp>
       <p:sp>
         <p:nvSpPr>
-          <p:cNvPr id="144" name="Text 142"/>
+          <p:cNvPr id="140" name="Text 138"/>
           <p:cNvSpPr txBox="1"/>
           <p:nvPr/>
         </p:nvSpPr>
@@ -50289,7 +50150,7 @@
       </p:sp>
       <p:sp>
         <p:nvSpPr>
-          <p:cNvPr id="145" name="Shape 143"/>
+          <p:cNvPr id="141" name="Shape 139"/>
           <p:cNvSpPr/>
           <p:nvPr/>
         </p:nvSpPr>
@@ -50309,7 +50170,7 @@
       </p:sp>
       <p:sp>
         <p:nvSpPr>
-          <p:cNvPr id="146" name="Text 144"/>
+          <p:cNvPr id="142" name="Text 140"/>
           <p:cNvSpPr txBox="1"/>
           <p:nvPr/>
         </p:nvSpPr>
@@ -50348,7 +50209,7 @@
       </p:sp>
       <p:sp>
         <p:nvSpPr>
-          <p:cNvPr id="147" name="Text 145"/>
+          <p:cNvPr id="143" name="Text 141"/>
           <p:cNvSpPr txBox="1"/>
           <p:nvPr/>
         </p:nvSpPr>
@@ -50387,7 +50248,7 @@
       </p:sp>
       <p:sp>
         <p:nvSpPr>
-          <p:cNvPr id="148" name="Text 146"/>
+          <p:cNvPr id="144" name="Text 142"/>
           <p:cNvSpPr txBox="1"/>
           <p:nvPr/>
         </p:nvSpPr>
@@ -50426,7 +50287,7 @@
       </p:sp>
       <p:sp>
         <p:nvSpPr>
-          <p:cNvPr id="149" name="Text 147"/>
+          <p:cNvPr id="145" name="Text 143"/>
           <p:cNvSpPr txBox="1"/>
           <p:nvPr/>
         </p:nvSpPr>
@@ -50465,7 +50326,7 @@
       </p:sp>
       <p:sp>
         <p:nvSpPr>
-          <p:cNvPr id="150" name="Text 148"/>
+          <p:cNvPr id="146" name="Text 144"/>
           <p:cNvSpPr txBox="1"/>
           <p:nvPr/>
         </p:nvSpPr>
@@ -50504,7 +50365,7 @@
       </p:sp>
       <p:sp>
         <p:nvSpPr>
-          <p:cNvPr id="151" name="Shape 149"/>
+          <p:cNvPr id="147" name="Shape 145"/>
           <p:cNvSpPr/>
           <p:nvPr/>
         </p:nvSpPr>
@@ -50524,7 +50385,7 @@
       </p:sp>
       <p:sp>
         <p:nvSpPr>
-          <p:cNvPr id="152" name="Text 150"/>
+          <p:cNvPr id="148" name="Text 146"/>
           <p:cNvSpPr txBox="1"/>
           <p:nvPr/>
         </p:nvSpPr>
@@ -50563,7 +50424,7 @@
       </p:sp>
       <p:sp>
         <p:nvSpPr>
-          <p:cNvPr id="153" name="Text 151"/>
+          <p:cNvPr id="149" name="Text 147"/>
           <p:cNvSpPr txBox="1"/>
           <p:nvPr/>
         </p:nvSpPr>
@@ -50602,7 +50463,7 @@
       </p:sp>
       <p:sp>
         <p:nvSpPr>
-          <p:cNvPr id="154" name="Text 152"/>
+          <p:cNvPr id="150" name="Text 148"/>
           <p:cNvSpPr txBox="1"/>
           <p:nvPr/>
         </p:nvSpPr>
@@ -50641,7 +50502,7 @@
       </p:sp>
       <p:sp>
         <p:nvSpPr>
-          <p:cNvPr id="155" name="Text 153"/>
+          <p:cNvPr id="151" name="Text 149"/>
           <p:cNvSpPr txBox="1"/>
           <p:nvPr/>
         </p:nvSpPr>
@@ -50672,7 +50533,7 @@
                 <a:ea typeface="Poppins" pitchFamily="34" charset="-122"/>
                 <a:cs typeface="Poppins" pitchFamily="34" charset="-120"/>
               </a:rPr>
-              <a:t>11.5%</a:t>
+              <a:t>13.0%</a:t>
             </a:r>
             <a:endParaRPr lang="en-US" sz="750" dirty="0"/>
           </a:p>
@@ -50680,7 +50541,7 @@
       </p:sp>
       <p:sp>
         <p:nvSpPr>
-          <p:cNvPr id="156" name="Text 154"/>
+          <p:cNvPr id="152" name="Text 150"/>
           <p:cNvSpPr txBox="1"/>
           <p:nvPr/>
         </p:nvSpPr>
@@ -50719,7 +50580,7 @@
       </p:sp>
       <p:sp>
         <p:nvSpPr>
-          <p:cNvPr id="157" name="Text 155"/>
+          <p:cNvPr id="153" name="Text 151"/>
           <p:cNvSpPr txBox="1"/>
           <p:nvPr/>
         </p:nvSpPr>
@@ -50750,7 +50611,7 @@
                 <a:ea typeface="Poppins" pitchFamily="34" charset="-122"/>
                 <a:cs typeface="Poppins" pitchFamily="34" charset="-120"/>
               </a:rPr>
-              <a:t>Base is available staff × 38h: 9 every week except 28 Sep–4 Oct (7, Rhys and Rodney on leave). PS-pipeline tickets by Sydney week.</a:t>
+              <a:t>Base is available staff × 38h: 9 for the September weeks, 7 for 28 Sep–4 Oct (Rhys and Rodney on leave) and 8 for 12–18 Oct (Isayah on leave). PS-pipeline tickets by Sydney week.</a:t>
             </a:r>
             <a:endParaRPr lang="en-US" sz="580" dirty="0"/>
           </a:p>
@@ -50758,7 +50619,7 @@
       </p:sp>
       <p:sp>
         <p:nvSpPr>
-          <p:cNvPr id="158" name="Shape 156"/>
+          <p:cNvPr id="154" name="Shape 152"/>
           <p:cNvSpPr/>
           <p:nvPr/>
         </p:nvSpPr>
@@ -50787,7 +50648,7 @@
       </p:sp>
       <p:sp>
         <p:nvSpPr>
-          <p:cNvPr id="159" name="Text 157"/>
+          <p:cNvPr id="155" name="Text 153"/>
           <p:cNvSpPr txBox="1"/>
           <p:nvPr/>
         </p:nvSpPr>
@@ -50826,7 +50687,7 @@
       </p:sp>
       <p:sp>
         <p:nvSpPr>
-          <p:cNvPr id="160" name="Text 158"/>
+          <p:cNvPr id="156" name="Text 154"/>
           <p:cNvSpPr txBox="1"/>
           <p:nvPr/>
         </p:nvSpPr>
@@ -50888,7 +50749,7 @@
                 <a:ea typeface="Poppins" pitchFamily="34" charset="-122"/>
                 <a:cs typeface="Poppins" pitchFamily="34" charset="-120"/>
               </a:rPr>
-              <a:t>5–11 Oct went out at 21.25h (6.2%) and now reads 30.25h (8.8%); 21–27 Sep has grown again to 44.50h from the 20.75h first published. Only 28 Sep–4 Oct sits below its first number, and that is the attribution fix from last week. Treat 11.5% as a floor.</a:t>
+              <a:t>5–11 Oct went out at 21.25h (6.2%) and now reads 30.25h (8.8%); 21–27 Sep has grown again to 44.50h from the 20.75h first published. Only 28 Sep–4 Oct sits below its first number, and that is the attribution fix from last week. Treat 13.0% as a floor.</a:t>
             </a:r>
             <a:endParaRPr lang="en-US" sz="900" dirty="0"/>
           </a:p>
@@ -50936,7 +50797,7 @@
                 <a:ea typeface="Poppins" pitchFamily="34" charset="-122"/>
                 <a:cs typeface="Poppins" pitchFamily="34" charset="-120"/>
               </a:rPr>
-              <a:t>Rhys Woolcock 19.50h — half the week — against Joshua Casey 6.50h and Rodney Nolan 5.75h; Isayah Kuhlmann and Karim AlRifaii logged nothing. Strip Rhys out and utilisation is 5.8%.</a:t>
+              <a:t>Rhys Woolcock 19.50h — half the week — against Joshua Casey 6.50h and Rodney Nolan 5.75h; Karim AlRifaii logged nothing. Strip Rhys out and utilisation is 6.6%.</a:t>
             </a:r>
             <a:endParaRPr lang="en-US" sz="900" dirty="0"/>
           </a:p>
@@ -50944,7 +50805,7 @@
       </p:sp>
       <p:sp>
         <p:nvSpPr>
-          <p:cNvPr id="161" name="Shape 159"/>
+          <p:cNvPr id="157" name="Shape 155"/>
           <p:cNvSpPr/>
           <p:nvPr/>
         </p:nvSpPr>
@@ -50966,7 +50827,7 @@
       </p:sp>
       <p:sp>
         <p:nvSpPr>
-          <p:cNvPr id="162" name="Text 160"/>
+          <p:cNvPr id="158" name="Text 156"/>
           <p:cNvSpPr txBox="1"/>
           <p:nvPr/>
         </p:nvSpPr>

</xml_diff>